<commit_message>
docs: update pitch deck with new features and interview data
</commit_message>
<xml_diff>
--- a/docs/seguimed_pitch.pptx
+++ b/docs/seguimed_pitch.pptx
@@ -11338,7 +11338,7 @@
               <a:buChar char="•"/>
             </a:pPr>
             <a:r>
-              <a:rPr lang="en-US" sz="1200" dirty="0">
+              <a:rPr lang="en-US" sz="1150" dirty="0">
                 <a:solidFill>
                   <a:srgbClr val="085041"/>
                 </a:solidFill>
@@ -11348,7 +11348,7 @@
               </a:rPr>
               <a:t>Dashboard: 4 metricas de estado en tiempo real</a:t>
             </a:r>
-            <a:endParaRPr lang="en-US" sz="1200" dirty="0"/>
+            <a:endParaRPr lang="en-US" sz="1150" dirty="0"/>
           </a:p>
           <a:p>
             <a:pPr marL="342900" indent="-342900">
@@ -11356,7 +11356,7 @@
               <a:buChar char="•"/>
             </a:pPr>
             <a:r>
-              <a:rPr lang="en-US" sz="1200" dirty="0">
+              <a:rPr lang="en-US" sz="1150" dirty="0">
                 <a:solidFill>
                   <a:srgbClr val="085041"/>
                 </a:solidFill>
@@ -11364,9 +11364,9 @@
                 <a:ea typeface="Calibri" pitchFamily="34" charset="-122"/>
                 <a:cs typeface="Calibri" pitchFamily="34" charset="-120"/>
               </a:rPr>
-              <a:t>Mensajes personalizados por IA en espanol peruano</a:t>
-            </a:r>
-            <a:endParaRPr lang="en-US" sz="1200" dirty="0"/>
+              <a:t>Mensajes IA personalizados en espanol (DeepSeek-V3)</a:t>
+            </a:r>
+            <a:endParaRPr lang="en-US" sz="1150" dirty="0"/>
           </a:p>
           <a:p>
             <a:pPr marL="342900" indent="-342900">
@@ -11374,7 +11374,7 @@
               <a:buChar char="•"/>
             </a:pPr>
             <a:r>
-              <a:rPr lang="en-US" sz="1200" dirty="0">
+              <a:rPr lang="en-US" sz="1150" dirty="0">
                 <a:solidFill>
                   <a:srgbClr val="085041"/>
                 </a:solidFill>
@@ -11382,9 +11382,9 @@
                 <a:ea typeface="Calibri" pitchFamily="34" charset="-122"/>
                 <a:cs typeface="Calibri" pitchFamily="34" charset="-120"/>
               </a:rPr>
-              <a:t>Links WhatsApp con mensaje prellenado (1 clic)</a:t>
-            </a:r>
-            <a:endParaRPr lang="en-US" sz="1200" dirty="0"/>
+              <a:t>Links WhatsApp prellenados — medico solo toca Enviar</a:t>
+            </a:r>
+            <a:endParaRPr lang="en-US" sz="1150" dirty="0"/>
           </a:p>
           <a:p>
             <a:pPr marL="342900" indent="-342900">
@@ -11392,7 +11392,7 @@
               <a:buChar char="•"/>
             </a:pPr>
             <a:r>
-              <a:rPr lang="en-US" sz="1200" dirty="0">
+              <a:rPr lang="en-US" sz="1150" dirty="0">
                 <a:solidFill>
                   <a:srgbClr val="085041"/>
                 </a:solidFill>
@@ -11400,9 +11400,9 @@
                 <a:ea typeface="Calibri" pitchFamily="34" charset="-122"/>
                 <a:cs typeface="Calibri" pitchFamily="34" charset="-120"/>
               </a:rPr>
-              <a:t>Registro por nota de voz: Whisper transcribe + IA extrae datos</a:t>
-            </a:r>
-            <a:endParaRPr lang="en-US" sz="1200" dirty="0"/>
+              <a:t>Grabacion de voz en tiempo real (Whisper + IA extrae datos)</a:t>
+            </a:r>
+            <a:endParaRPr lang="en-US" sz="1150" dirty="0"/>
           </a:p>
           <a:p>
             <a:pPr marL="342900" indent="-342900">
@@ -11410,7 +11410,7 @@
               <a:buChar char="•"/>
             </a:pPr>
             <a:r>
-              <a:rPr lang="en-US" sz="1200" dirty="0">
+              <a:rPr lang="en-US" sz="1150" dirty="0">
                 <a:solidFill>
                   <a:srgbClr val="085041"/>
                 </a:solidFill>
@@ -11418,9 +11418,27 @@
                 <a:ea typeface="Calibri" pitchFamily="34" charset="-122"/>
                 <a:cs typeface="Calibri" pitchFamily="34" charset="-120"/>
               </a:rPr>
-              <a:t>Campanas de temporada para toda la base de pacientes</a:t>
-            </a:r>
-            <a:endParaRPr lang="en-US" sz="1200" dirty="0"/>
+              <a:t>Historial completo de citas y contactos por paciente</a:t>
+            </a:r>
+            <a:endParaRPr lang="en-US" sz="1150" dirty="0"/>
+          </a:p>
+          <a:p>
+            <a:pPr marL="342900" indent="-342900">
+              <a:buSzPct val="100000"/>
+              <a:buChar char="•"/>
+            </a:pPr>
+            <a:r>
+              <a:rPr lang="en-US" sz="1150" dirty="0">
+                <a:solidFill>
+                  <a:srgbClr val="085041"/>
+                </a:solidFill>
+                <a:latin typeface="Calibri" pitchFamily="34" charset="0"/>
+                <a:ea typeface="Calibri" pitchFamily="34" charset="-122"/>
+                <a:cs typeface="Calibri" pitchFamily="34" charset="-120"/>
+              </a:rPr>
+              <a:t>Integracion Google Calendar para citas pasadas y futuras</a:t>
+            </a:r>
+            <a:endParaRPr lang="en-US" sz="1150" dirty="0"/>
           </a:p>
         </p:txBody>
       </p:sp>

</xml_diff>